<commit_message>
Apply FLE visual charte to 1312 PPTX: Poppins font, brand colors, university footer
</commit_message>
<xml_diff>
--- a/cours/Dialogues_Anglais/Presentations_PPTX/Niveau 1/Dialogue_01_Greeting_the_Family.pptx
+++ b/cours/Dialogues_Anglais/Presentations_PPTX/Niveau 1/Dialogue_01_Greeting_the_Family.pptx
@@ -2844,7 +2844,7 @@
           <a:solidFill>
             <a:schemeClr val="tx1"/>
           </a:solidFill>
-          <a:latin typeface="+mj-lt"/>
+          <a:latin typeface="Poppins"/>
           <a:ea typeface="+mj-ea"/>
           <a:cs typeface="+mj-cs"/>
         </a:defRPr>
@@ -2861,7 +2861,7 @@
           <a:solidFill>
             <a:schemeClr val="tx1"/>
           </a:solidFill>
-          <a:latin typeface="+mn-lt"/>
+          <a:latin typeface="Poppins"/>
           <a:ea typeface="+mn-ea"/>
           <a:cs typeface="+mn-cs"/>
         </a:defRPr>
@@ -2876,7 +2876,7 @@
           <a:solidFill>
             <a:schemeClr val="tx1"/>
           </a:solidFill>
-          <a:latin typeface="+mn-lt"/>
+          <a:latin typeface="Poppins"/>
           <a:ea typeface="+mn-ea"/>
           <a:cs typeface="+mn-cs"/>
         </a:defRPr>
@@ -2891,7 +2891,7 @@
           <a:solidFill>
             <a:schemeClr val="tx1"/>
           </a:solidFill>
-          <a:latin typeface="+mn-lt"/>
+          <a:latin typeface="Poppins"/>
           <a:ea typeface="+mn-ea"/>
           <a:cs typeface="+mn-cs"/>
         </a:defRPr>
@@ -2906,7 +2906,7 @@
           <a:solidFill>
             <a:schemeClr val="tx1"/>
           </a:solidFill>
-          <a:latin typeface="+mn-lt"/>
+          <a:latin typeface="Poppins"/>
           <a:ea typeface="+mn-ea"/>
           <a:cs typeface="+mn-cs"/>
         </a:defRPr>
@@ -2921,7 +2921,7 @@
           <a:solidFill>
             <a:schemeClr val="tx1"/>
           </a:solidFill>
-          <a:latin typeface="+mn-lt"/>
+          <a:latin typeface="Poppins"/>
           <a:ea typeface="+mn-ea"/>
           <a:cs typeface="+mn-cs"/>
         </a:defRPr>
@@ -2936,7 +2936,7 @@
           <a:solidFill>
             <a:schemeClr val="tx1"/>
           </a:solidFill>
-          <a:latin typeface="+mn-lt"/>
+          <a:latin typeface="Poppins"/>
           <a:ea typeface="+mn-ea"/>
           <a:cs typeface="+mn-cs"/>
         </a:defRPr>
@@ -2951,7 +2951,7 @@
           <a:solidFill>
             <a:schemeClr val="tx1"/>
           </a:solidFill>
-          <a:latin typeface="+mn-lt"/>
+          <a:latin typeface="Poppins"/>
           <a:ea typeface="+mn-ea"/>
           <a:cs typeface="+mn-cs"/>
         </a:defRPr>
@@ -2966,7 +2966,7 @@
           <a:solidFill>
             <a:schemeClr val="tx1"/>
           </a:solidFill>
-          <a:latin typeface="+mn-lt"/>
+          <a:latin typeface="Poppins"/>
           <a:ea typeface="+mn-ea"/>
           <a:cs typeface="+mn-cs"/>
         </a:defRPr>
@@ -2981,7 +2981,7 @@
           <a:solidFill>
             <a:schemeClr val="tx1"/>
           </a:solidFill>
-          <a:latin typeface="+mn-lt"/>
+          <a:latin typeface="Poppins"/>
           <a:ea typeface="+mn-ea"/>
           <a:cs typeface="+mn-cs"/>
         </a:defRPr>
@@ -2996,7 +2996,7 @@
           <a:solidFill>
             <a:schemeClr val="tx1"/>
           </a:solidFill>
-          <a:latin typeface="+mn-lt"/>
+          <a:latin typeface="Poppins"/>
           <a:ea typeface="+mn-ea"/>
           <a:cs typeface="+mn-cs"/>
         </a:defRPr>
@@ -3006,7 +3006,7 @@
           <a:solidFill>
             <a:schemeClr val="tx1"/>
           </a:solidFill>
-          <a:latin typeface="+mn-lt"/>
+          <a:latin typeface="Poppins"/>
           <a:ea typeface="+mn-ea"/>
           <a:cs typeface="+mn-cs"/>
         </a:defRPr>
@@ -3016,7 +3016,7 @@
           <a:solidFill>
             <a:schemeClr val="tx1"/>
           </a:solidFill>
-          <a:latin typeface="+mn-lt"/>
+          <a:latin typeface="Poppins"/>
           <a:ea typeface="+mn-ea"/>
           <a:cs typeface="+mn-cs"/>
         </a:defRPr>
@@ -3026,7 +3026,7 @@
           <a:solidFill>
             <a:schemeClr val="tx1"/>
           </a:solidFill>
-          <a:latin typeface="+mn-lt"/>
+          <a:latin typeface="Poppins"/>
           <a:ea typeface="+mn-ea"/>
           <a:cs typeface="+mn-cs"/>
         </a:defRPr>
@@ -3036,7 +3036,7 @@
           <a:solidFill>
             <a:schemeClr val="tx1"/>
           </a:solidFill>
-          <a:latin typeface="+mn-lt"/>
+          <a:latin typeface="Poppins"/>
           <a:ea typeface="+mn-ea"/>
           <a:cs typeface="+mn-cs"/>
         </a:defRPr>
@@ -3046,7 +3046,7 @@
           <a:solidFill>
             <a:schemeClr val="tx1"/>
           </a:solidFill>
-          <a:latin typeface="+mn-lt"/>
+          <a:latin typeface="Poppins"/>
           <a:ea typeface="+mn-ea"/>
           <a:cs typeface="+mn-cs"/>
         </a:defRPr>
@@ -3056,7 +3056,7 @@
           <a:solidFill>
             <a:schemeClr val="tx1"/>
           </a:solidFill>
-          <a:latin typeface="+mn-lt"/>
+          <a:latin typeface="Poppins"/>
           <a:ea typeface="+mn-ea"/>
           <a:cs typeface="+mn-cs"/>
         </a:defRPr>
@@ -3066,7 +3066,7 @@
           <a:solidFill>
             <a:schemeClr val="tx1"/>
           </a:solidFill>
-          <a:latin typeface="+mn-lt"/>
+          <a:latin typeface="Poppins"/>
           <a:ea typeface="+mn-ea"/>
           <a:cs typeface="+mn-cs"/>
         </a:defRPr>
@@ -3076,7 +3076,7 @@
           <a:solidFill>
             <a:schemeClr val="tx1"/>
           </a:solidFill>
-          <a:latin typeface="+mn-lt"/>
+          <a:latin typeface="Poppins"/>
           <a:ea typeface="+mn-ea"/>
           <a:cs typeface="+mn-cs"/>
         </a:defRPr>
@@ -3091,9 +3091,7 @@
   <p:cSld>
     <p:bg>
       <p:bgPr>
-        <a:solidFill>
-          <a:srgbClr val="1A5C33"/>
-        </a:solidFill>
+        <a:solidFill>val="006847"/&gt;</a:solidFill>
         <a:effectLst/>
       </p:bgPr>
     </p:bg>
@@ -3128,10 +3126,8 @@
           <a:p>
             <a:pPr algn="ctr">
               <a:defRPr sz="3200" b="1">
-                <a:solidFill>
-                  <a:srgbClr val="FFFFFF"/>
-                </a:solidFill>
-                <a:latin typeface="Calibri"/>
+                <a:solidFill>val="FFFFFF"/&gt;</a:solidFill>
+                <a:latin typeface="Poppins"/>
               </a:defRPr>
             </a:pPr>
             <a:r>
@@ -3164,10 +3160,8 @@
           <a:p>
             <a:pPr algn="ctr">
               <a:defRPr sz="2000" b="0">
-                <a:solidFill>
-                  <a:srgbClr val="C5D9C7"/>
-                </a:solidFill>
-                <a:latin typeface="Calibri"/>
+                <a:solidFill>val="DFE5EA"/&gt;</a:solidFill>
+                <a:latin typeface="Poppins"/>
               </a:defRPr>
             </a:pPr>
             <a:r>
@@ -3200,10 +3194,8 @@
           <a:p>
             <a:pPr algn="ctr">
               <a:defRPr sz="1400" b="0">
-                <a:solidFill>
-                  <a:srgbClr val="A0C0A8"/>
-                </a:solidFill>
-                <a:latin typeface="Calibri"/>
+                <a:solidFill>val="B7C9BE"/&gt;</a:solidFill>
+                <a:latin typeface="Poppins"/>
               </a:defRPr>
             </a:pPr>
             <a:r>
@@ -3236,14 +3228,53 @@
           <a:p>
             <a:pPr algn="ctr">
               <a:defRPr sz="1200" b="0">
+                <a:solidFill>val="93B39E"/&gt;</a:solidFill>
+                <a:latin typeface="Poppins"/>
+              </a:defRPr>
+            </a:pPr>
+            <a:r>
+              <a:t>Dialogue 1 / 23</a:t>
+            </a:r>
+          </a:p>
+        </p:txBody>
+      </p:sp>
+      <p:sp>
+        <p:nvSpPr>
+          <p:cNvPr id="990001" name="Pied de page FLE"/>
+          <p:cNvSpPr>
+            <a:spLocks noGrp="1"/>
+          </p:cNvSpPr>
+          <p:nvPr/>
+        </p:nvSpPr>
+        <p:spPr>
+          <a:xfrm>
+            <a:off x="2880360" y="640080"/>
+            <a:ext cx="4572000" cy="274320"/>
+          </a:xfrm>
+          <a:prstGeom prst="rect">
+            <a:avLst/>
+          </a:prstGeom>
+        </p:spPr>
+        <p:txBody>
+          <a:bodyPr anchor="b"/>
+          <a:lstStyle/>
+          <a:p>
+            <a:pPr algn="r">
+              <a:defRPr sz="900">
                 <a:solidFill>
-                  <a:srgbClr val="80B088"/>
+                  <a:srgbClr val="9AA7B6"/>
                 </a:solidFill>
-                <a:latin typeface="Calibri"/>
+                <a:latin typeface="Poppins"/>
               </a:defRPr>
             </a:pPr>
             <a:r>
-              <a:t>Dialogue 1 / 23</a:t>
+              <a:rPr lang="fr-FR" sz="900">
+                <a:solidFill>
+                  <a:srgbClr val="9AA7B6"/>
+                </a:solidFill>
+                <a:latin typeface="Poppins"/>
+              </a:rPr>
+              <a:t>Université de Mostaganem — Dr. Madani BELACEL</a:t>
             </a:r>
           </a:p>
         </p:txBody>
@@ -3261,9 +3292,7 @@
   <p:cSld>
     <p:bg>
       <p:bgPr>
-        <a:solidFill>
-          <a:srgbClr val="FFFFFF"/>
-        </a:solidFill>
+        <a:solidFill>val="FFFFFF"/&gt;</a:solidFill>
         <a:effectLst/>
       </p:bgPr>
     </p:bg>
@@ -3288,9 +3317,7 @@
           <a:prstGeom prst="rect">
             <a:avLst/>
           </a:prstGeom>
-          <a:solidFill>
-            <a:srgbClr val="2C6E49"/>
-          </a:solidFill>
+          <a:solidFill>val="00875B"/&gt;</a:solidFill>
           <a:ln>
             <a:noFill/>
           </a:ln>
@@ -3341,10 +3368,8 @@
           <a:p>
             <a:pPr algn="l">
               <a:defRPr sz="1000" b="0">
-                <a:solidFill>
-                  <a:srgbClr val="666666"/>
-                </a:solidFill>
-                <a:latin typeface="Calibri"/>
+                <a:solidFill>val="69788B"/&gt;</a:solidFill>
+                <a:latin typeface="Poppins"/>
               </a:defRPr>
             </a:pPr>
             <a:r>
@@ -3377,10 +3402,8 @@
           <a:p>
             <a:pPr algn="r">
               <a:defRPr sz="1000" b="0">
-                <a:solidFill>
-                  <a:srgbClr val="666666"/>
-                </a:solidFill>
-                <a:latin typeface="Calibri"/>
+                <a:solidFill>val="69788B"/&gt;</a:solidFill>
+                <a:latin typeface="Poppins"/>
               </a:defRPr>
             </a:pPr>
             <a:r>
@@ -3413,10 +3436,8 @@
           <a:p>
             <a:pPr algn="l">
               <a:defRPr sz="2400" b="1">
-                <a:solidFill>
-                  <a:srgbClr val="B45309"/>
-                </a:solidFill>
-                <a:latin typeface="Calibri"/>
+                <a:solidFill>val="F0B429"/&gt;</a:solidFill>
+                <a:latin typeface="Poppins"/>
               </a:defRPr>
             </a:pPr>
             <a:r>
@@ -3449,10 +3470,8 @@
           <a:p>
             <a:pPr algn="l">
               <a:defRPr sz="2200" b="0">
-                <a:solidFill>
-                  <a:srgbClr val="222222"/>
-                </a:solidFill>
-                <a:latin typeface="Calibri"/>
+                <a:solidFill>val="22344A"/&gt;</a:solidFill>
+                <a:latin typeface="Poppins"/>
               </a:defRPr>
             </a:pPr>
             <a:r>
@@ -3475,9 +3494,7 @@
           <a:prstGeom prst="rect">
             <a:avLst/>
           </a:prstGeom>
-          <a:solidFill>
-            <a:srgbClr val="E8F0E9"/>
-          </a:solidFill>
+          <a:solidFill>val="F4F6F8"/&gt;</a:solidFill>
           <a:ln>
             <a:noFill/>
           </a:ln>
@@ -3528,10 +3545,8 @@
           <a:p>
             <a:pPr algn="l">
               <a:defRPr sz="1100" b="1">
-                <a:solidFill>
-                  <a:srgbClr val="2C6E49"/>
-                </a:solidFill>
-                <a:latin typeface="Calibri"/>
+                <a:solidFill>val="00875B"/&gt;</a:solidFill>
+                <a:latin typeface="Poppins"/>
               </a:defRPr>
             </a:pPr>
             <a:r>
@@ -3564,10 +3579,8 @@
           <a:p>
             <a:pPr algn="r">
               <a:defRPr sz="2000" b="0">
-                <a:solidFill>
-                  <a:srgbClr val="1A3C6E"/>
-                </a:solidFill>
-                <a:latin typeface="Traditional Arabic"/>
+                <a:solidFill>val="34495E"/&gt;</a:solidFill>
+                <a:latin typeface="Poppins"/>
               </a:defRPr>
             </a:pPr>
             <a:r>
@@ -3600,10 +3613,8 @@
           <a:p>
             <a:pPr algn="l">
               <a:defRPr sz="900" b="0">
-                <a:solidFill>
-                  <a:srgbClr val="666666"/>
-                </a:solidFill>
-                <a:latin typeface="Calibri"/>
+                <a:solidFill>val="69788B"/&gt;</a:solidFill>
+                <a:latin typeface="Poppins"/>
               </a:defRPr>
             </a:pPr>
             <a:r>
@@ -3626,9 +3637,7 @@
           <a:prstGeom prst="rect">
             <a:avLst/>
           </a:prstGeom>
-          <a:solidFill>
-            <a:srgbClr val="1A5C33"/>
-          </a:solidFill>
+          <a:solidFill>val="006847"/&gt;</a:solidFill>
           <a:ln>
             <a:noFill/>
           </a:ln>
@@ -3652,6 +3661,47 @@
           <a:lstStyle/>
           <a:p>
             <a:pPr algn="ctr"/>
+          </a:p>
+        </p:txBody>
+      </p:sp>
+      <p:sp>
+        <p:nvSpPr>
+          <p:cNvPr id="990001" name="Pied de page FLE"/>
+          <p:cNvSpPr>
+            <a:spLocks noGrp="1"/>
+          </p:cNvSpPr>
+          <p:nvPr/>
+        </p:nvSpPr>
+        <p:spPr>
+          <a:xfrm>
+            <a:off x="4343400" y="-384048"/>
+            <a:ext cx="4572000" cy="274320"/>
+          </a:xfrm>
+          <a:prstGeom prst="rect">
+            <a:avLst/>
+          </a:prstGeom>
+        </p:spPr>
+        <p:txBody>
+          <a:bodyPr anchor="b"/>
+          <a:lstStyle/>
+          <a:p>
+            <a:pPr algn="r">
+              <a:defRPr sz="900">
+                <a:solidFill>
+                  <a:srgbClr val="9AA7B6"/>
+                </a:solidFill>
+                <a:latin typeface="Poppins"/>
+              </a:defRPr>
+            </a:pPr>
+            <a:r>
+              <a:rPr lang="fr-FR" sz="900">
+                <a:solidFill>
+                  <a:srgbClr val="9AA7B6"/>
+                </a:solidFill>
+                <a:latin typeface="Poppins"/>
+              </a:rPr>
+              <a:t>Université de Mostaganem — Dr. Madani BELACEL</a:t>
+            </a:r>
           </a:p>
         </p:txBody>
       </p:sp>
@@ -3668,9 +3718,7 @@
   <p:cSld>
     <p:bg>
       <p:bgPr>
-        <a:solidFill>
-          <a:srgbClr val="FFFFFF"/>
-        </a:solidFill>
+        <a:solidFill>val="FFFFFF"/&gt;</a:solidFill>
         <a:effectLst/>
       </p:bgPr>
     </p:bg>
@@ -3695,9 +3743,7 @@
           <a:prstGeom prst="rect">
             <a:avLst/>
           </a:prstGeom>
-          <a:solidFill>
-            <a:srgbClr val="2C6E49"/>
-          </a:solidFill>
+          <a:solidFill>val="00875B"/&gt;</a:solidFill>
           <a:ln>
             <a:noFill/>
           </a:ln>
@@ -3748,10 +3794,8 @@
           <a:p>
             <a:pPr algn="l">
               <a:defRPr sz="1000" b="0">
-                <a:solidFill>
-                  <a:srgbClr val="666666"/>
-                </a:solidFill>
-                <a:latin typeface="Calibri"/>
+                <a:solidFill>val="69788B"/&gt;</a:solidFill>
+                <a:latin typeface="Poppins"/>
               </a:defRPr>
             </a:pPr>
             <a:r>
@@ -3784,10 +3828,8 @@
           <a:p>
             <a:pPr algn="r">
               <a:defRPr sz="1000" b="0">
-                <a:solidFill>
-                  <a:srgbClr val="666666"/>
-                </a:solidFill>
-                <a:latin typeface="Calibri"/>
+                <a:solidFill>val="69788B"/&gt;</a:solidFill>
+                <a:latin typeface="Poppins"/>
               </a:defRPr>
             </a:pPr>
             <a:r>
@@ -3820,10 +3862,8 @@
           <a:p>
             <a:pPr algn="l">
               <a:defRPr sz="2400" b="1">
-                <a:solidFill>
-                  <a:srgbClr val="B45309"/>
-                </a:solidFill>
-                <a:latin typeface="Calibri"/>
+                <a:solidFill>val="F0B429"/&gt;</a:solidFill>
+                <a:latin typeface="Poppins"/>
               </a:defRPr>
             </a:pPr>
             <a:r>
@@ -3856,10 +3896,8 @@
           <a:p>
             <a:pPr algn="l">
               <a:defRPr sz="2200" b="0">
-                <a:solidFill>
-                  <a:srgbClr val="222222"/>
-                </a:solidFill>
-                <a:latin typeface="Calibri"/>
+                <a:solidFill>val="22344A"/&gt;</a:solidFill>
+                <a:latin typeface="Poppins"/>
               </a:defRPr>
             </a:pPr>
             <a:r>
@@ -3882,9 +3920,7 @@
           <a:prstGeom prst="rect">
             <a:avLst/>
           </a:prstGeom>
-          <a:solidFill>
-            <a:srgbClr val="E8F0E9"/>
-          </a:solidFill>
+          <a:solidFill>val="F4F6F8"/&gt;</a:solidFill>
           <a:ln>
             <a:noFill/>
           </a:ln>
@@ -3935,10 +3971,8 @@
           <a:p>
             <a:pPr algn="l">
               <a:defRPr sz="1100" b="1">
-                <a:solidFill>
-                  <a:srgbClr val="2C6E49"/>
-                </a:solidFill>
-                <a:latin typeface="Calibri"/>
+                <a:solidFill>val="00875B"/&gt;</a:solidFill>
+                <a:latin typeface="Poppins"/>
               </a:defRPr>
             </a:pPr>
             <a:r>
@@ -3971,10 +4005,8 @@
           <a:p>
             <a:pPr algn="r">
               <a:defRPr sz="2000" b="0">
-                <a:solidFill>
-                  <a:srgbClr val="1A3C6E"/>
-                </a:solidFill>
-                <a:latin typeface="Traditional Arabic"/>
+                <a:solidFill>val="34495E"/&gt;</a:solidFill>
+                <a:latin typeface="Poppins"/>
               </a:defRPr>
             </a:pPr>
             <a:r>
@@ -4007,10 +4039,8 @@
           <a:p>
             <a:pPr algn="l">
               <a:defRPr sz="900" b="0">
-                <a:solidFill>
-                  <a:srgbClr val="666666"/>
-                </a:solidFill>
-                <a:latin typeface="Calibri"/>
+                <a:solidFill>val="69788B"/&gt;</a:solidFill>
+                <a:latin typeface="Poppins"/>
               </a:defRPr>
             </a:pPr>
             <a:r>
@@ -4033,9 +4063,7 @@
           <a:prstGeom prst="rect">
             <a:avLst/>
           </a:prstGeom>
-          <a:solidFill>
-            <a:srgbClr val="1A5C33"/>
-          </a:solidFill>
+          <a:solidFill>val="006847"/&gt;</a:solidFill>
           <a:ln>
             <a:noFill/>
           </a:ln>
@@ -4059,6 +4087,47 @@
           <a:lstStyle/>
           <a:p>
             <a:pPr algn="ctr"/>
+          </a:p>
+        </p:txBody>
+      </p:sp>
+      <p:sp>
+        <p:nvSpPr>
+          <p:cNvPr id="990001" name="Pied de page FLE"/>
+          <p:cNvSpPr>
+            <a:spLocks noGrp="1"/>
+          </p:cNvSpPr>
+          <p:nvPr/>
+        </p:nvSpPr>
+        <p:spPr>
+          <a:xfrm>
+            <a:off x="4343400" y="-384048"/>
+            <a:ext cx="4572000" cy="274320"/>
+          </a:xfrm>
+          <a:prstGeom prst="rect">
+            <a:avLst/>
+          </a:prstGeom>
+        </p:spPr>
+        <p:txBody>
+          <a:bodyPr anchor="b"/>
+          <a:lstStyle/>
+          <a:p>
+            <a:pPr algn="r">
+              <a:defRPr sz="900">
+                <a:solidFill>
+                  <a:srgbClr val="9AA7B6"/>
+                </a:solidFill>
+                <a:latin typeface="Poppins"/>
+              </a:defRPr>
+            </a:pPr>
+            <a:r>
+              <a:rPr lang="fr-FR" sz="900">
+                <a:solidFill>
+                  <a:srgbClr val="9AA7B6"/>
+                </a:solidFill>
+                <a:latin typeface="Poppins"/>
+              </a:rPr>
+              <a:t>Université de Mostaganem — Dr. Madani BELACEL</a:t>
+            </a:r>
           </a:p>
         </p:txBody>
       </p:sp>
@@ -4075,9 +4144,7 @@
   <p:cSld>
     <p:bg>
       <p:bgPr>
-        <a:solidFill>
-          <a:srgbClr val="FFFFFF"/>
-        </a:solidFill>
+        <a:solidFill>val="FFFFFF"/&gt;</a:solidFill>
         <a:effectLst/>
       </p:bgPr>
     </p:bg>
@@ -4102,9 +4169,7 @@
           <a:prstGeom prst="rect">
             <a:avLst/>
           </a:prstGeom>
-          <a:solidFill>
-            <a:srgbClr val="2C6E49"/>
-          </a:solidFill>
+          <a:solidFill>val="00875B"/&gt;</a:solidFill>
           <a:ln>
             <a:noFill/>
           </a:ln>
@@ -4155,10 +4220,8 @@
           <a:p>
             <a:pPr algn="l">
               <a:defRPr sz="1000" b="0">
-                <a:solidFill>
-                  <a:srgbClr val="666666"/>
-                </a:solidFill>
-                <a:latin typeface="Calibri"/>
+                <a:solidFill>val="69788B"/&gt;</a:solidFill>
+                <a:latin typeface="Poppins"/>
               </a:defRPr>
             </a:pPr>
             <a:r>
@@ -4191,10 +4254,8 @@
           <a:p>
             <a:pPr algn="r">
               <a:defRPr sz="1000" b="0">
-                <a:solidFill>
-                  <a:srgbClr val="666666"/>
-                </a:solidFill>
-                <a:latin typeface="Calibri"/>
+                <a:solidFill>val="69788B"/&gt;</a:solidFill>
+                <a:latin typeface="Poppins"/>
               </a:defRPr>
             </a:pPr>
             <a:r>
@@ -4227,10 +4288,8 @@
           <a:p>
             <a:pPr algn="l">
               <a:defRPr sz="2400" b="1">
-                <a:solidFill>
-                  <a:srgbClr val="B45309"/>
-                </a:solidFill>
-                <a:latin typeface="Calibri"/>
+                <a:solidFill>val="F0B429"/&gt;</a:solidFill>
+                <a:latin typeface="Poppins"/>
               </a:defRPr>
             </a:pPr>
             <a:r>
@@ -4263,10 +4322,8 @@
           <a:p>
             <a:pPr algn="l">
               <a:defRPr sz="2200" b="0">
-                <a:solidFill>
-                  <a:srgbClr val="222222"/>
-                </a:solidFill>
-                <a:latin typeface="Calibri"/>
+                <a:solidFill>val="22344A"/&gt;</a:solidFill>
+                <a:latin typeface="Poppins"/>
               </a:defRPr>
             </a:pPr>
             <a:r>
@@ -4289,9 +4346,7 @@
           <a:prstGeom prst="rect">
             <a:avLst/>
           </a:prstGeom>
-          <a:solidFill>
-            <a:srgbClr val="E8F0E9"/>
-          </a:solidFill>
+          <a:solidFill>val="F4F6F8"/&gt;</a:solidFill>
           <a:ln>
             <a:noFill/>
           </a:ln>
@@ -4342,10 +4397,8 @@
           <a:p>
             <a:pPr algn="l">
               <a:defRPr sz="1100" b="1">
-                <a:solidFill>
-                  <a:srgbClr val="2C6E49"/>
-                </a:solidFill>
-                <a:latin typeface="Calibri"/>
+                <a:solidFill>val="00875B"/&gt;</a:solidFill>
+                <a:latin typeface="Poppins"/>
               </a:defRPr>
             </a:pPr>
             <a:r>
@@ -4378,10 +4431,8 @@
           <a:p>
             <a:pPr algn="r">
               <a:defRPr sz="2000" b="0">
-                <a:solidFill>
-                  <a:srgbClr val="1A3C6E"/>
-                </a:solidFill>
-                <a:latin typeface="Traditional Arabic"/>
+                <a:solidFill>val="34495E"/&gt;</a:solidFill>
+                <a:latin typeface="Poppins"/>
               </a:defRPr>
             </a:pPr>
             <a:r>
@@ -4414,10 +4465,8 @@
           <a:p>
             <a:pPr algn="l">
               <a:defRPr sz="900" b="0">
-                <a:solidFill>
-                  <a:srgbClr val="666666"/>
-                </a:solidFill>
-                <a:latin typeface="Calibri"/>
+                <a:solidFill>val="69788B"/&gt;</a:solidFill>
+                <a:latin typeface="Poppins"/>
               </a:defRPr>
             </a:pPr>
             <a:r>
@@ -4440,9 +4489,7 @@
           <a:prstGeom prst="rect">
             <a:avLst/>
           </a:prstGeom>
-          <a:solidFill>
-            <a:srgbClr val="1A5C33"/>
-          </a:solidFill>
+          <a:solidFill>val="006847"/&gt;</a:solidFill>
           <a:ln>
             <a:noFill/>
           </a:ln>
@@ -4466,6 +4513,47 @@
           <a:lstStyle/>
           <a:p>
             <a:pPr algn="ctr"/>
+          </a:p>
+        </p:txBody>
+      </p:sp>
+      <p:sp>
+        <p:nvSpPr>
+          <p:cNvPr id="990001" name="Pied de page FLE"/>
+          <p:cNvSpPr>
+            <a:spLocks noGrp="1"/>
+          </p:cNvSpPr>
+          <p:nvPr/>
+        </p:nvSpPr>
+        <p:spPr>
+          <a:xfrm>
+            <a:off x="4343400" y="-384048"/>
+            <a:ext cx="4572000" cy="274320"/>
+          </a:xfrm>
+          <a:prstGeom prst="rect">
+            <a:avLst/>
+          </a:prstGeom>
+        </p:spPr>
+        <p:txBody>
+          <a:bodyPr anchor="b"/>
+          <a:lstStyle/>
+          <a:p>
+            <a:pPr algn="r">
+              <a:defRPr sz="900">
+                <a:solidFill>
+                  <a:srgbClr val="9AA7B6"/>
+                </a:solidFill>
+                <a:latin typeface="Poppins"/>
+              </a:defRPr>
+            </a:pPr>
+            <a:r>
+              <a:rPr lang="fr-FR" sz="900">
+                <a:solidFill>
+                  <a:srgbClr val="9AA7B6"/>
+                </a:solidFill>
+                <a:latin typeface="Poppins"/>
+              </a:rPr>
+              <a:t>Université de Mostaganem — Dr. Madani BELACEL</a:t>
+            </a:r>
           </a:p>
         </p:txBody>
       </p:sp>
@@ -4482,9 +4570,7 @@
   <p:cSld>
     <p:bg>
       <p:bgPr>
-        <a:solidFill>
-          <a:srgbClr val="FFFFFF"/>
-        </a:solidFill>
+        <a:solidFill>val="FFFFFF"/&gt;</a:solidFill>
         <a:effectLst/>
       </p:bgPr>
     </p:bg>
@@ -4509,9 +4595,7 @@
           <a:prstGeom prst="rect">
             <a:avLst/>
           </a:prstGeom>
-          <a:solidFill>
-            <a:srgbClr val="2C6E49"/>
-          </a:solidFill>
+          <a:solidFill>val="00875B"/&gt;</a:solidFill>
           <a:ln>
             <a:noFill/>
           </a:ln>
@@ -4562,10 +4646,8 @@
           <a:p>
             <a:pPr algn="l">
               <a:defRPr sz="1000" b="0">
-                <a:solidFill>
-                  <a:srgbClr val="666666"/>
-                </a:solidFill>
-                <a:latin typeface="Calibri"/>
+                <a:solidFill>val="69788B"/&gt;</a:solidFill>
+                <a:latin typeface="Poppins"/>
               </a:defRPr>
             </a:pPr>
             <a:r>
@@ -4598,10 +4680,8 @@
           <a:p>
             <a:pPr algn="r">
               <a:defRPr sz="1000" b="0">
-                <a:solidFill>
-                  <a:srgbClr val="666666"/>
-                </a:solidFill>
-                <a:latin typeface="Calibri"/>
+                <a:solidFill>val="69788B"/&gt;</a:solidFill>
+                <a:latin typeface="Poppins"/>
               </a:defRPr>
             </a:pPr>
             <a:r>
@@ -4634,10 +4714,8 @@
           <a:p>
             <a:pPr algn="l">
               <a:defRPr sz="2400" b="1">
-                <a:solidFill>
-                  <a:srgbClr val="B45309"/>
-                </a:solidFill>
-                <a:latin typeface="Calibri"/>
+                <a:solidFill>val="F0B429"/&gt;</a:solidFill>
+                <a:latin typeface="Poppins"/>
               </a:defRPr>
             </a:pPr>
             <a:r>
@@ -4670,10 +4748,8 @@
           <a:p>
             <a:pPr algn="l">
               <a:defRPr sz="2200" b="0">
-                <a:solidFill>
-                  <a:srgbClr val="222222"/>
-                </a:solidFill>
-                <a:latin typeface="Calibri"/>
+                <a:solidFill>val="22344A"/&gt;</a:solidFill>
+                <a:latin typeface="Poppins"/>
               </a:defRPr>
             </a:pPr>
             <a:r>
@@ -4696,9 +4772,7 @@
           <a:prstGeom prst="rect">
             <a:avLst/>
           </a:prstGeom>
-          <a:solidFill>
-            <a:srgbClr val="E8F0E9"/>
-          </a:solidFill>
+          <a:solidFill>val="F4F6F8"/&gt;</a:solidFill>
           <a:ln>
             <a:noFill/>
           </a:ln>
@@ -4749,10 +4823,8 @@
           <a:p>
             <a:pPr algn="l">
               <a:defRPr sz="1100" b="1">
-                <a:solidFill>
-                  <a:srgbClr val="2C6E49"/>
-                </a:solidFill>
-                <a:latin typeface="Calibri"/>
+                <a:solidFill>val="00875B"/&gt;</a:solidFill>
+                <a:latin typeface="Poppins"/>
               </a:defRPr>
             </a:pPr>
             <a:r>
@@ -4785,10 +4857,8 @@
           <a:p>
             <a:pPr algn="r">
               <a:defRPr sz="2000" b="0">
-                <a:solidFill>
-                  <a:srgbClr val="1A3C6E"/>
-                </a:solidFill>
-                <a:latin typeface="Traditional Arabic"/>
+                <a:solidFill>val="34495E"/&gt;</a:solidFill>
+                <a:latin typeface="Poppins"/>
               </a:defRPr>
             </a:pPr>
             <a:r>
@@ -4821,10 +4891,8 @@
           <a:p>
             <a:pPr algn="l">
               <a:defRPr sz="900" b="0">
-                <a:solidFill>
-                  <a:srgbClr val="666666"/>
-                </a:solidFill>
-                <a:latin typeface="Calibri"/>
+                <a:solidFill>val="69788B"/&gt;</a:solidFill>
+                <a:latin typeface="Poppins"/>
               </a:defRPr>
             </a:pPr>
             <a:r>
@@ -4847,9 +4915,7 @@
           <a:prstGeom prst="rect">
             <a:avLst/>
           </a:prstGeom>
-          <a:solidFill>
-            <a:srgbClr val="1A5C33"/>
-          </a:solidFill>
+          <a:solidFill>val="006847"/&gt;</a:solidFill>
           <a:ln>
             <a:noFill/>
           </a:ln>
@@ -4873,6 +4939,47 @@
           <a:lstStyle/>
           <a:p>
             <a:pPr algn="ctr"/>
+          </a:p>
+        </p:txBody>
+      </p:sp>
+      <p:sp>
+        <p:nvSpPr>
+          <p:cNvPr id="990001" name="Pied de page FLE"/>
+          <p:cNvSpPr>
+            <a:spLocks noGrp="1"/>
+          </p:cNvSpPr>
+          <p:nvPr/>
+        </p:nvSpPr>
+        <p:spPr>
+          <a:xfrm>
+            <a:off x="4343400" y="-384048"/>
+            <a:ext cx="4572000" cy="274320"/>
+          </a:xfrm>
+          <a:prstGeom prst="rect">
+            <a:avLst/>
+          </a:prstGeom>
+        </p:spPr>
+        <p:txBody>
+          <a:bodyPr anchor="b"/>
+          <a:lstStyle/>
+          <a:p>
+            <a:pPr algn="r">
+              <a:defRPr sz="900">
+                <a:solidFill>
+                  <a:srgbClr val="9AA7B6"/>
+                </a:solidFill>
+                <a:latin typeface="Poppins"/>
+              </a:defRPr>
+            </a:pPr>
+            <a:r>
+              <a:rPr lang="fr-FR" sz="900">
+                <a:solidFill>
+                  <a:srgbClr val="9AA7B6"/>
+                </a:solidFill>
+                <a:latin typeface="Poppins"/>
+              </a:rPr>
+              <a:t>Université de Mostaganem — Dr. Madani BELACEL</a:t>
+            </a:r>
           </a:p>
         </p:txBody>
       </p:sp>
@@ -4889,9 +4996,7 @@
   <p:cSld>
     <p:bg>
       <p:bgPr>
-        <a:solidFill>
-          <a:srgbClr val="FFFFFF"/>
-        </a:solidFill>
+        <a:solidFill>val="FFFFFF"/&gt;</a:solidFill>
         <a:effectLst/>
       </p:bgPr>
     </p:bg>
@@ -4916,9 +5021,7 @@
           <a:prstGeom prst="rect">
             <a:avLst/>
           </a:prstGeom>
-          <a:solidFill>
-            <a:srgbClr val="2C6E49"/>
-          </a:solidFill>
+          <a:solidFill>val="00875B"/&gt;</a:solidFill>
           <a:ln>
             <a:noFill/>
           </a:ln>
@@ -4969,10 +5072,8 @@
           <a:p>
             <a:pPr algn="l">
               <a:defRPr sz="1000" b="0">
-                <a:solidFill>
-                  <a:srgbClr val="666666"/>
-                </a:solidFill>
-                <a:latin typeface="Calibri"/>
+                <a:solidFill>val="69788B"/&gt;</a:solidFill>
+                <a:latin typeface="Poppins"/>
               </a:defRPr>
             </a:pPr>
             <a:r>
@@ -5005,10 +5106,8 @@
           <a:p>
             <a:pPr algn="r">
               <a:defRPr sz="1000" b="0">
-                <a:solidFill>
-                  <a:srgbClr val="666666"/>
-                </a:solidFill>
-                <a:latin typeface="Calibri"/>
+                <a:solidFill>val="69788B"/&gt;</a:solidFill>
+                <a:latin typeface="Poppins"/>
               </a:defRPr>
             </a:pPr>
             <a:r>
@@ -5041,10 +5140,8 @@
           <a:p>
             <a:pPr algn="l">
               <a:defRPr sz="2400" b="1">
-                <a:solidFill>
-                  <a:srgbClr val="B45309"/>
-                </a:solidFill>
-                <a:latin typeface="Calibri"/>
+                <a:solidFill>val="F0B429"/&gt;</a:solidFill>
+                <a:latin typeface="Poppins"/>
               </a:defRPr>
             </a:pPr>
             <a:r>
@@ -5077,10 +5174,8 @@
           <a:p>
             <a:pPr algn="l">
               <a:defRPr sz="2200" b="0">
-                <a:solidFill>
-                  <a:srgbClr val="222222"/>
-                </a:solidFill>
-                <a:latin typeface="Calibri"/>
+                <a:solidFill>val="22344A"/&gt;</a:solidFill>
+                <a:latin typeface="Poppins"/>
               </a:defRPr>
             </a:pPr>
             <a:r>
@@ -5103,9 +5198,7 @@
           <a:prstGeom prst="rect">
             <a:avLst/>
           </a:prstGeom>
-          <a:solidFill>
-            <a:srgbClr val="E8F0E9"/>
-          </a:solidFill>
+          <a:solidFill>val="F4F6F8"/&gt;</a:solidFill>
           <a:ln>
             <a:noFill/>
           </a:ln>
@@ -5156,10 +5249,8 @@
           <a:p>
             <a:pPr algn="l">
               <a:defRPr sz="1100" b="1">
-                <a:solidFill>
-                  <a:srgbClr val="2C6E49"/>
-                </a:solidFill>
-                <a:latin typeface="Calibri"/>
+                <a:solidFill>val="00875B"/&gt;</a:solidFill>
+                <a:latin typeface="Poppins"/>
               </a:defRPr>
             </a:pPr>
             <a:r>
@@ -5192,10 +5283,8 @@
           <a:p>
             <a:pPr algn="r">
               <a:defRPr sz="2000" b="0">
-                <a:solidFill>
-                  <a:srgbClr val="1A3C6E"/>
-                </a:solidFill>
-                <a:latin typeface="Traditional Arabic"/>
+                <a:solidFill>val="34495E"/&gt;</a:solidFill>
+                <a:latin typeface="Poppins"/>
               </a:defRPr>
             </a:pPr>
             <a:r>
@@ -5228,10 +5317,8 @@
           <a:p>
             <a:pPr algn="l">
               <a:defRPr sz="900" b="0">
-                <a:solidFill>
-                  <a:srgbClr val="666666"/>
-                </a:solidFill>
-                <a:latin typeface="Calibri"/>
+                <a:solidFill>val="69788B"/&gt;</a:solidFill>
+                <a:latin typeface="Poppins"/>
               </a:defRPr>
             </a:pPr>
             <a:r>
@@ -5254,9 +5341,7 @@
           <a:prstGeom prst="rect">
             <a:avLst/>
           </a:prstGeom>
-          <a:solidFill>
-            <a:srgbClr val="1A5C33"/>
-          </a:solidFill>
+          <a:solidFill>val="006847"/&gt;</a:solidFill>
           <a:ln>
             <a:noFill/>
           </a:ln>
@@ -5280,6 +5365,47 @@
           <a:lstStyle/>
           <a:p>
             <a:pPr algn="ctr"/>
+          </a:p>
+        </p:txBody>
+      </p:sp>
+      <p:sp>
+        <p:nvSpPr>
+          <p:cNvPr id="990001" name="Pied de page FLE"/>
+          <p:cNvSpPr>
+            <a:spLocks noGrp="1"/>
+          </p:cNvSpPr>
+          <p:nvPr/>
+        </p:nvSpPr>
+        <p:spPr>
+          <a:xfrm>
+            <a:off x="4343400" y="-384048"/>
+            <a:ext cx="4572000" cy="274320"/>
+          </a:xfrm>
+          <a:prstGeom prst="rect">
+            <a:avLst/>
+          </a:prstGeom>
+        </p:spPr>
+        <p:txBody>
+          <a:bodyPr anchor="b"/>
+          <a:lstStyle/>
+          <a:p>
+            <a:pPr algn="r">
+              <a:defRPr sz="900">
+                <a:solidFill>
+                  <a:srgbClr val="9AA7B6"/>
+                </a:solidFill>
+                <a:latin typeface="Poppins"/>
+              </a:defRPr>
+            </a:pPr>
+            <a:r>
+              <a:rPr lang="fr-FR" sz="900">
+                <a:solidFill>
+                  <a:srgbClr val="9AA7B6"/>
+                </a:solidFill>
+                <a:latin typeface="Poppins"/>
+              </a:rPr>
+              <a:t>Université de Mostaganem — Dr. Madani BELACEL</a:t>
+            </a:r>
           </a:p>
         </p:txBody>
       </p:sp>
@@ -5296,9 +5422,7 @@
   <p:cSld>
     <p:bg>
       <p:bgPr>
-        <a:solidFill>
-          <a:srgbClr val="FFFFFF"/>
-        </a:solidFill>
+        <a:solidFill>val="FFFFFF"/&gt;</a:solidFill>
         <a:effectLst/>
       </p:bgPr>
     </p:bg>
@@ -5323,9 +5447,7 @@
           <a:prstGeom prst="rect">
             <a:avLst/>
           </a:prstGeom>
-          <a:solidFill>
-            <a:srgbClr val="2C6E49"/>
-          </a:solidFill>
+          <a:solidFill>val="00875B"/&gt;</a:solidFill>
           <a:ln>
             <a:noFill/>
           </a:ln>
@@ -5376,10 +5498,8 @@
           <a:p>
             <a:pPr algn="l">
               <a:defRPr sz="1000" b="0">
-                <a:solidFill>
-                  <a:srgbClr val="666666"/>
-                </a:solidFill>
-                <a:latin typeface="Calibri"/>
+                <a:solidFill>val="69788B"/&gt;</a:solidFill>
+                <a:latin typeface="Poppins"/>
               </a:defRPr>
             </a:pPr>
             <a:r>
@@ -5412,10 +5532,8 @@
           <a:p>
             <a:pPr algn="r">
               <a:defRPr sz="1000" b="0">
-                <a:solidFill>
-                  <a:srgbClr val="666666"/>
-                </a:solidFill>
-                <a:latin typeface="Calibri"/>
+                <a:solidFill>val="69788B"/&gt;</a:solidFill>
+                <a:latin typeface="Poppins"/>
               </a:defRPr>
             </a:pPr>
             <a:r>
@@ -5448,10 +5566,8 @@
           <a:p>
             <a:pPr algn="l">
               <a:defRPr sz="2400" b="1">
-                <a:solidFill>
-                  <a:srgbClr val="B45309"/>
-                </a:solidFill>
-                <a:latin typeface="Calibri"/>
+                <a:solidFill>val="F0B429"/&gt;</a:solidFill>
+                <a:latin typeface="Poppins"/>
               </a:defRPr>
             </a:pPr>
             <a:r>
@@ -5484,10 +5600,8 @@
           <a:p>
             <a:pPr algn="l">
               <a:defRPr sz="2200" b="0">
-                <a:solidFill>
-                  <a:srgbClr val="222222"/>
-                </a:solidFill>
-                <a:latin typeface="Calibri"/>
+                <a:solidFill>val="22344A"/&gt;</a:solidFill>
+                <a:latin typeface="Poppins"/>
               </a:defRPr>
             </a:pPr>
             <a:r>
@@ -5510,9 +5624,7 @@
           <a:prstGeom prst="rect">
             <a:avLst/>
           </a:prstGeom>
-          <a:solidFill>
-            <a:srgbClr val="E8F0E9"/>
-          </a:solidFill>
+          <a:solidFill>val="F4F6F8"/&gt;</a:solidFill>
           <a:ln>
             <a:noFill/>
           </a:ln>
@@ -5563,10 +5675,8 @@
           <a:p>
             <a:pPr algn="l">
               <a:defRPr sz="1100" b="1">
-                <a:solidFill>
-                  <a:srgbClr val="2C6E49"/>
-                </a:solidFill>
-                <a:latin typeface="Calibri"/>
+                <a:solidFill>val="00875B"/&gt;</a:solidFill>
+                <a:latin typeface="Poppins"/>
               </a:defRPr>
             </a:pPr>
             <a:r>
@@ -5599,10 +5709,8 @@
           <a:p>
             <a:pPr algn="r">
               <a:defRPr sz="2000" b="0">
-                <a:solidFill>
-                  <a:srgbClr val="1A3C6E"/>
-                </a:solidFill>
-                <a:latin typeface="Traditional Arabic"/>
+                <a:solidFill>val="34495E"/&gt;</a:solidFill>
+                <a:latin typeface="Poppins"/>
               </a:defRPr>
             </a:pPr>
             <a:r>
@@ -5635,10 +5743,8 @@
           <a:p>
             <a:pPr algn="l">
               <a:defRPr sz="900" b="0">
-                <a:solidFill>
-                  <a:srgbClr val="666666"/>
-                </a:solidFill>
-                <a:latin typeface="Calibri"/>
+                <a:solidFill>val="69788B"/&gt;</a:solidFill>
+                <a:latin typeface="Poppins"/>
               </a:defRPr>
             </a:pPr>
             <a:r>
@@ -5661,9 +5767,7 @@
           <a:prstGeom prst="rect">
             <a:avLst/>
           </a:prstGeom>
-          <a:solidFill>
-            <a:srgbClr val="1A5C33"/>
-          </a:solidFill>
+          <a:solidFill>val="006847"/&gt;</a:solidFill>
           <a:ln>
             <a:noFill/>
           </a:ln>
@@ -5687,6 +5791,47 @@
           <a:lstStyle/>
           <a:p>
             <a:pPr algn="ctr"/>
+          </a:p>
+        </p:txBody>
+      </p:sp>
+      <p:sp>
+        <p:nvSpPr>
+          <p:cNvPr id="990001" name="Pied de page FLE"/>
+          <p:cNvSpPr>
+            <a:spLocks noGrp="1"/>
+          </p:cNvSpPr>
+          <p:nvPr/>
+        </p:nvSpPr>
+        <p:spPr>
+          <a:xfrm>
+            <a:off x="4343400" y="-384048"/>
+            <a:ext cx="4572000" cy="274320"/>
+          </a:xfrm>
+          <a:prstGeom prst="rect">
+            <a:avLst/>
+          </a:prstGeom>
+        </p:spPr>
+        <p:txBody>
+          <a:bodyPr anchor="b"/>
+          <a:lstStyle/>
+          <a:p>
+            <a:pPr algn="r">
+              <a:defRPr sz="900">
+                <a:solidFill>
+                  <a:srgbClr val="9AA7B6"/>
+                </a:solidFill>
+                <a:latin typeface="Poppins"/>
+              </a:defRPr>
+            </a:pPr>
+            <a:r>
+              <a:rPr lang="fr-FR" sz="900">
+                <a:solidFill>
+                  <a:srgbClr val="9AA7B6"/>
+                </a:solidFill>
+                <a:latin typeface="Poppins"/>
+              </a:rPr>
+              <a:t>Université de Mostaganem — Dr. Madani BELACEL</a:t>
+            </a:r>
           </a:p>
         </p:txBody>
       </p:sp>
@@ -5703,9 +5848,7 @@
   <p:cSld>
     <p:bg>
       <p:bgPr>
-        <a:solidFill>
-          <a:srgbClr val="FFFFFF"/>
-        </a:solidFill>
+        <a:solidFill>val="FFFFFF"/&gt;</a:solidFill>
         <a:effectLst/>
       </p:bgPr>
     </p:bg>
@@ -5730,9 +5873,7 @@
           <a:prstGeom prst="rect">
             <a:avLst/>
           </a:prstGeom>
-          <a:solidFill>
-            <a:srgbClr val="2C6E49"/>
-          </a:solidFill>
+          <a:solidFill>val="00875B"/&gt;</a:solidFill>
           <a:ln>
             <a:noFill/>
           </a:ln>
@@ -5783,10 +5924,8 @@
           <a:p>
             <a:pPr algn="l">
               <a:defRPr sz="1000" b="0">
-                <a:solidFill>
-                  <a:srgbClr val="666666"/>
-                </a:solidFill>
-                <a:latin typeface="Calibri"/>
+                <a:solidFill>val="69788B"/&gt;</a:solidFill>
+                <a:latin typeface="Poppins"/>
               </a:defRPr>
             </a:pPr>
             <a:r>
@@ -5819,10 +5958,8 @@
           <a:p>
             <a:pPr algn="r">
               <a:defRPr sz="1000" b="0">
-                <a:solidFill>
-                  <a:srgbClr val="666666"/>
-                </a:solidFill>
-                <a:latin typeface="Calibri"/>
+                <a:solidFill>val="69788B"/&gt;</a:solidFill>
+                <a:latin typeface="Poppins"/>
               </a:defRPr>
             </a:pPr>
             <a:r>
@@ -5855,10 +5992,8 @@
           <a:p>
             <a:pPr algn="l">
               <a:defRPr sz="2400" b="1">
-                <a:solidFill>
-                  <a:srgbClr val="B45309"/>
-                </a:solidFill>
-                <a:latin typeface="Calibri"/>
+                <a:solidFill>val="F0B429"/&gt;</a:solidFill>
+                <a:latin typeface="Poppins"/>
               </a:defRPr>
             </a:pPr>
             <a:r>
@@ -5891,10 +6026,8 @@
           <a:p>
             <a:pPr algn="l">
               <a:defRPr sz="2200" b="0">
-                <a:solidFill>
-                  <a:srgbClr val="222222"/>
-                </a:solidFill>
-                <a:latin typeface="Calibri"/>
+                <a:solidFill>val="22344A"/&gt;</a:solidFill>
+                <a:latin typeface="Poppins"/>
               </a:defRPr>
             </a:pPr>
             <a:r>
@@ -5917,9 +6050,7 @@
           <a:prstGeom prst="rect">
             <a:avLst/>
           </a:prstGeom>
-          <a:solidFill>
-            <a:srgbClr val="E8F0E9"/>
-          </a:solidFill>
+          <a:solidFill>val="F4F6F8"/&gt;</a:solidFill>
           <a:ln>
             <a:noFill/>
           </a:ln>
@@ -5970,10 +6101,8 @@
           <a:p>
             <a:pPr algn="l">
               <a:defRPr sz="1100" b="1">
-                <a:solidFill>
-                  <a:srgbClr val="2C6E49"/>
-                </a:solidFill>
-                <a:latin typeface="Calibri"/>
+                <a:solidFill>val="00875B"/&gt;</a:solidFill>
+                <a:latin typeface="Poppins"/>
               </a:defRPr>
             </a:pPr>
             <a:r>
@@ -6006,10 +6135,8 @@
           <a:p>
             <a:pPr algn="r">
               <a:defRPr sz="2000" b="0">
-                <a:solidFill>
-                  <a:srgbClr val="1A3C6E"/>
-                </a:solidFill>
-                <a:latin typeface="Traditional Arabic"/>
+                <a:solidFill>val="34495E"/&gt;</a:solidFill>
+                <a:latin typeface="Poppins"/>
               </a:defRPr>
             </a:pPr>
             <a:r>
@@ -6042,10 +6169,8 @@
           <a:p>
             <a:pPr algn="l">
               <a:defRPr sz="900" b="0">
-                <a:solidFill>
-                  <a:srgbClr val="666666"/>
-                </a:solidFill>
-                <a:latin typeface="Calibri"/>
+                <a:solidFill>val="69788B"/&gt;</a:solidFill>
+                <a:latin typeface="Poppins"/>
               </a:defRPr>
             </a:pPr>
             <a:r>
@@ -6068,9 +6193,7 @@
           <a:prstGeom prst="rect">
             <a:avLst/>
           </a:prstGeom>
-          <a:solidFill>
-            <a:srgbClr val="1A5C33"/>
-          </a:solidFill>
+          <a:solidFill>val="006847"/&gt;</a:solidFill>
           <a:ln>
             <a:noFill/>
           </a:ln>
@@ -6094,6 +6217,47 @@
           <a:lstStyle/>
           <a:p>
             <a:pPr algn="ctr"/>
+          </a:p>
+        </p:txBody>
+      </p:sp>
+      <p:sp>
+        <p:nvSpPr>
+          <p:cNvPr id="990001" name="Pied de page FLE"/>
+          <p:cNvSpPr>
+            <a:spLocks noGrp="1"/>
+          </p:cNvSpPr>
+          <p:nvPr/>
+        </p:nvSpPr>
+        <p:spPr>
+          <a:xfrm>
+            <a:off x="4343400" y="-384048"/>
+            <a:ext cx="4572000" cy="274320"/>
+          </a:xfrm>
+          <a:prstGeom prst="rect">
+            <a:avLst/>
+          </a:prstGeom>
+        </p:spPr>
+        <p:txBody>
+          <a:bodyPr anchor="b"/>
+          <a:lstStyle/>
+          <a:p>
+            <a:pPr algn="r">
+              <a:defRPr sz="900">
+                <a:solidFill>
+                  <a:srgbClr val="9AA7B6"/>
+                </a:solidFill>
+                <a:latin typeface="Poppins"/>
+              </a:defRPr>
+            </a:pPr>
+            <a:r>
+              <a:rPr lang="fr-FR" sz="900">
+                <a:solidFill>
+                  <a:srgbClr val="9AA7B6"/>
+                </a:solidFill>
+                <a:latin typeface="Poppins"/>
+              </a:rPr>
+              <a:t>Université de Mostaganem — Dr. Madani BELACEL</a:t>
+            </a:r>
           </a:p>
         </p:txBody>
       </p:sp>
@@ -6110,9 +6274,7 @@
   <p:cSld>
     <p:bg>
       <p:bgPr>
-        <a:solidFill>
-          <a:srgbClr val="FFFFFF"/>
-        </a:solidFill>
+        <a:solidFill>val="FFFFFF"/&gt;</a:solidFill>
         <a:effectLst/>
       </p:bgPr>
     </p:bg>
@@ -6137,9 +6299,7 @@
           <a:prstGeom prst="rect">
             <a:avLst/>
           </a:prstGeom>
-          <a:solidFill>
-            <a:srgbClr val="2C6E49"/>
-          </a:solidFill>
+          <a:solidFill>val="00875B"/&gt;</a:solidFill>
           <a:ln>
             <a:noFill/>
           </a:ln>
@@ -6190,10 +6350,8 @@
           <a:p>
             <a:pPr algn="l">
               <a:defRPr sz="1000" b="0">
-                <a:solidFill>
-                  <a:srgbClr val="666666"/>
-                </a:solidFill>
-                <a:latin typeface="Calibri"/>
+                <a:solidFill>val="69788B"/&gt;</a:solidFill>
+                <a:latin typeface="Poppins"/>
               </a:defRPr>
             </a:pPr>
             <a:r>
@@ -6226,10 +6384,8 @@
           <a:p>
             <a:pPr algn="r">
               <a:defRPr sz="1000" b="0">
-                <a:solidFill>
-                  <a:srgbClr val="666666"/>
-                </a:solidFill>
-                <a:latin typeface="Calibri"/>
+                <a:solidFill>val="69788B"/&gt;</a:solidFill>
+                <a:latin typeface="Poppins"/>
               </a:defRPr>
             </a:pPr>
             <a:r>
@@ -6262,10 +6418,8 @@
           <a:p>
             <a:pPr algn="l">
               <a:defRPr sz="2400" b="1">
-                <a:solidFill>
-                  <a:srgbClr val="B45309"/>
-                </a:solidFill>
-                <a:latin typeface="Calibri"/>
+                <a:solidFill>val="F0B429"/&gt;</a:solidFill>
+                <a:latin typeface="Poppins"/>
               </a:defRPr>
             </a:pPr>
             <a:r>
@@ -6298,10 +6452,8 @@
           <a:p>
             <a:pPr algn="l">
               <a:defRPr sz="2200" b="0">
-                <a:solidFill>
-                  <a:srgbClr val="222222"/>
-                </a:solidFill>
-                <a:latin typeface="Calibri"/>
+                <a:solidFill>val="22344A"/&gt;</a:solidFill>
+                <a:latin typeface="Poppins"/>
               </a:defRPr>
             </a:pPr>
             <a:r>
@@ -6324,9 +6476,7 @@
           <a:prstGeom prst="rect">
             <a:avLst/>
           </a:prstGeom>
-          <a:solidFill>
-            <a:srgbClr val="E8F0E9"/>
-          </a:solidFill>
+          <a:solidFill>val="F4F6F8"/&gt;</a:solidFill>
           <a:ln>
             <a:noFill/>
           </a:ln>
@@ -6377,10 +6527,8 @@
           <a:p>
             <a:pPr algn="l">
               <a:defRPr sz="1100" b="1">
-                <a:solidFill>
-                  <a:srgbClr val="2C6E49"/>
-                </a:solidFill>
-                <a:latin typeface="Calibri"/>
+                <a:solidFill>val="00875B"/&gt;</a:solidFill>
+                <a:latin typeface="Poppins"/>
               </a:defRPr>
             </a:pPr>
             <a:r>
@@ -6413,10 +6561,8 @@
           <a:p>
             <a:pPr algn="r">
               <a:defRPr sz="2000" b="0">
-                <a:solidFill>
-                  <a:srgbClr val="1A3C6E"/>
-                </a:solidFill>
-                <a:latin typeface="Traditional Arabic"/>
+                <a:solidFill>val="34495E"/&gt;</a:solidFill>
+                <a:latin typeface="Poppins"/>
               </a:defRPr>
             </a:pPr>
             <a:r>
@@ -6449,10 +6595,8 @@
           <a:p>
             <a:pPr algn="l">
               <a:defRPr sz="900" b="0">
-                <a:solidFill>
-                  <a:srgbClr val="666666"/>
-                </a:solidFill>
-                <a:latin typeface="Calibri"/>
+                <a:solidFill>val="69788B"/&gt;</a:solidFill>
+                <a:latin typeface="Poppins"/>
               </a:defRPr>
             </a:pPr>
             <a:r>
@@ -6475,9 +6619,7 @@
           <a:prstGeom prst="rect">
             <a:avLst/>
           </a:prstGeom>
-          <a:solidFill>
-            <a:srgbClr val="1A5C33"/>
-          </a:solidFill>
+          <a:solidFill>val="006847"/&gt;</a:solidFill>
           <a:ln>
             <a:noFill/>
           </a:ln>
@@ -6501,6 +6643,47 @@
           <a:lstStyle/>
           <a:p>
             <a:pPr algn="ctr"/>
+          </a:p>
+        </p:txBody>
+      </p:sp>
+      <p:sp>
+        <p:nvSpPr>
+          <p:cNvPr id="990001" name="Pied de page FLE"/>
+          <p:cNvSpPr>
+            <a:spLocks noGrp="1"/>
+          </p:cNvSpPr>
+          <p:nvPr/>
+        </p:nvSpPr>
+        <p:spPr>
+          <a:xfrm>
+            <a:off x="4343400" y="-384048"/>
+            <a:ext cx="4572000" cy="274320"/>
+          </a:xfrm>
+          <a:prstGeom prst="rect">
+            <a:avLst/>
+          </a:prstGeom>
+        </p:spPr>
+        <p:txBody>
+          <a:bodyPr anchor="b"/>
+          <a:lstStyle/>
+          <a:p>
+            <a:pPr algn="r">
+              <a:defRPr sz="900">
+                <a:solidFill>
+                  <a:srgbClr val="9AA7B6"/>
+                </a:solidFill>
+                <a:latin typeface="Poppins"/>
+              </a:defRPr>
+            </a:pPr>
+            <a:r>
+              <a:rPr lang="fr-FR" sz="900">
+                <a:solidFill>
+                  <a:srgbClr val="9AA7B6"/>
+                </a:solidFill>
+                <a:latin typeface="Poppins"/>
+              </a:rPr>
+              <a:t>Université de Mostaganem — Dr. Madani BELACEL</a:t>
+            </a:r>
           </a:p>
         </p:txBody>
       </p:sp>
@@ -6555,7 +6738,7 @@
     </a:clrScheme>
     <a:fontScheme name="Office">
       <a:majorFont>
-        <a:latin typeface="Calibri"/>
+        <a:latin typeface="Poppins"/>
         <a:ea typeface=""/>
         <a:cs typeface=""/>
         <a:font script="Jpan" typeface="ＭＳ Ｐゴシック"/>
@@ -6590,7 +6773,7 @@
         <a:font script="Geor" typeface="Sylfaen"/>
       </a:majorFont>
       <a:minorFont>
-        <a:latin typeface="Calibri"/>
+        <a:latin typeface="Poppins"/>
         <a:ea typeface=""/>
         <a:cs typeface=""/>
         <a:font script="Jpan" typeface="ＭＳ Ｐゴシック"/>

</xml_diff>